<commit_message>
refactor(core-ui-pdf-crypto): Enhance UI, PDF signature handling, and trust store logic
- Refactor UI button creation for better consistency and tooltip handling.
- Improve PDF signature verification to associate visual locations on pages.
- Enhance trust store manager to check issuer-principal relationships for trust anchors.
- Update error handling in MainWindow to suppress alerts for user-cancelled operations.
</commit_message>
<xml_diff>
--- a/samples/sample_presentation.pptx
+++ b/samples/sample_presentation.pptx
@@ -3095,7 +3095,7 @@
                 <a:solidFill>
                   <a:srgbClr val="104473"/>
                 </a:solidFill>
-                <a:latin typeface="Segoe UI"/>
+                <a:latin typeface="Calibri"/>
               </a:rPr>
               <a:t>Oqteris Office Suite</a:t>
             </a:r>
@@ -3136,7 +3136,7 @@
                 <a:solidFill>
                   <a:srgbClr val="646464"/>
                 </a:solidFill>
-                <a:latin typeface="Segoe UI"/>
+                <a:latin typeface="Calibri"/>
               </a:rPr>
               <a:t>Independent, Modern Cross-Platform Office Productivity</a:t>
             </a:r>
@@ -3202,7 +3202,7 @@
                 <a:solidFill>
                   <a:srgbClr val="104473"/>
                 </a:solidFill>
-                <a:latin typeface="Segoe UI"/>
+                <a:latin typeface="Calibri"/>
               </a:rPr>
               <a:t>Productivity Applications</a:t>
             </a:r>
@@ -3243,7 +3243,7 @@
                 <a:solidFill>
                   <a:srgbClr val="1E1E1E"/>
                 </a:solidFill>
-                <a:latin typeface="Segoe UI"/>
+                <a:latin typeface="Calibri"/>
               </a:rPr>
               <a:t>• Oqteris Writer: Standalone Word Processor with DOCX layout &amp; pagination</a:t>
             </a:r>
@@ -3254,7 +3254,7 @@
                 <a:solidFill>
                   <a:srgbClr val="1E1E1E"/>
                 </a:solidFill>
-                <a:latin typeface="Segoe UI"/>
+                <a:latin typeface="Calibri"/>
               </a:rPr>
               <a:t>• Oqteris Calc: Virtualized Canvas Spreadsheet with DAG formula recalculation</a:t>
             </a:r>
@@ -3265,7 +3265,7 @@
                 <a:solidFill>
                   <a:srgbClr val="1E1E1E"/>
                 </a:solidFill>
-                <a:latin typeface="Segoe UI"/>
+                <a:latin typeface="Calibri"/>
               </a:rPr>
               <a:t>• Oqteris Impress: Presentation Canvas with transitions &amp; slideshow mode</a:t>
             </a:r>
@@ -3276,7 +3276,7 @@
                 <a:solidFill>
                   <a:srgbClr val="1E1E1E"/>
                 </a:solidFill>
-                <a:latin typeface="Segoe UI"/>
+                <a:latin typeface="Calibri"/>
               </a:rPr>
               <a:t>• Oqteris PDF: Fast PDF viewer with cryptographic signature &amp; trust verification</a:t>
             </a:r>
@@ -3342,7 +3342,7 @@
                 <a:solidFill>
                   <a:srgbClr val="104473"/>
                 </a:solidFill>
-                <a:latin typeface="Segoe UI"/>
+                <a:latin typeface="Calibri"/>
               </a:rPr>
               <a:t>Vector Geometry &amp; Custom Visuals</a:t>
             </a:r>
@@ -3440,7 +3440,7 @@
                 <a:solidFill>
                   <a:srgbClr val="3C3C3C"/>
                 </a:solidFill>
-                <a:latin typeface="Segoe UI"/>
+                <a:latin typeface="Calibri"/>
               </a:rPr>
               <a:t>Shapes are rendered cleanly on JavaFX Canvas and preserved accurately through standard Office Open XML (PPTX) export and import pipelines.</a:t>
             </a:r>

</xml_diff>